<commit_message>
Replace dense tech story with child-friendly snow leopard feature
Use a recent World Snow Leopard Day photo and animated GIF so the third slide is easier for kindergarten children to understand and present.
</commit_message>
<xml_diff>
--- a/daily-news/2026-10-27/今日新闻-2026-10-27.pptx
+++ b/daily-news/2026-10-27/今日新闻-2026-10-27.pptx
@@ -4886,7 +4886,7 @@
         </p:nvSpPr>
         <p:spPr>
           <a:xfrm>
-            <a:off x="548640" y="411480"/>
+            <a:off x="548640" y="384048"/>
             <a:ext cx="1005840" cy="411480"/>
           </a:xfrm>
           <a:prstGeom prst="roundRect">
@@ -4930,7 +4930,7 @@
         </p:nvSpPr>
         <p:spPr>
           <a:xfrm>
-            <a:off x="548640" y="411480"/>
+            <a:off x="548640" y="384048"/>
             <a:ext cx="1005840" cy="411480"/>
           </a:xfrm>
           <a:prstGeom prst="rect">
@@ -4966,7 +4966,7 @@
         </p:nvSpPr>
         <p:spPr>
           <a:xfrm>
-            <a:off x="1737360" y="411480"/>
+            <a:off x="1737360" y="384048"/>
             <a:ext cx="2743200" cy="411480"/>
           </a:xfrm>
           <a:prstGeom prst="rect">
@@ -4989,7 +4989,7 @@
                 <a:latin typeface="Microsoft YaHei"/>
                 <a:ea typeface="Microsoft YaHei"/>
               </a:rPr>
-              <a:t>未来的科技</a:t>
+              <a:t>世界雪豹日</a:t>
             </a:r>
           </a:p>
         </p:txBody>
@@ -5002,8 +5002,8 @@
         </p:nvSpPr>
         <p:spPr>
           <a:xfrm>
-            <a:off x="457200" y="1005840"/>
-            <a:ext cx="6126480" cy="5212080"/>
+            <a:off x="411480" y="914400"/>
+            <a:ext cx="6537960" cy="5257800"/>
           </a:xfrm>
           <a:prstGeom prst="roundRect">
             <a:avLst/>
@@ -5040,7 +5040,7 @@
       </p:sp>
       <p:pic>
         <p:nvPicPr>
-          <p:cNvPr id="7" name="Picture 6" descr="science-forum.jpg"/>
+          <p:cNvPr id="7" name="Picture 6" descr="snow-leopard-photo.jpg"/>
           <p:cNvPicPr>
             <a:picLocks noChangeAspect="1"/>
           </p:cNvPicPr>
@@ -5054,8 +5054,8 @@
         </p:blipFill>
         <p:spPr>
           <a:xfrm>
-            <a:off x="548640" y="1097280"/>
-            <a:ext cx="5943600" cy="5029200"/>
+            <a:off x="530352" y="1033271"/>
+            <a:ext cx="6309360" cy="4124136"/>
           </a:xfrm>
           <a:prstGeom prst="rect">
             <a:avLst/>
@@ -5070,8 +5070,8 @@
         </p:nvSpPr>
         <p:spPr>
           <a:xfrm>
-            <a:off x="6858000" y="1097280"/>
-            <a:ext cx="4846320" cy="1097280"/>
+            <a:off x="7223760" y="960120"/>
+            <a:ext cx="4480560" cy="914400"/>
           </a:xfrm>
           <a:prstGeom prst="rect">
             <a:avLst/>
@@ -5086,106 +5086,34 @@
           <a:p>
             <a:pPr algn="l"/>
             <a:r>
-              <a:rPr sz="3600" b="1">
+              <a:rPr sz="3400" b="1">
                 <a:solidFill>
                   <a:srgbClr val="254537"/>
                 </a:solidFill>
                 <a:latin typeface="Microsoft YaHei"/>
                 <a:ea typeface="Microsoft YaHei"/>
               </a:rPr>
-              <a:t>科学家发布十大前瞻技术</a:t>
-            </a:r>
-          </a:p>
-        </p:txBody>
-      </p:sp>
-      <p:sp>
-        <p:nvSpPr>
-          <p:cNvPr id="9" name="TextBox 8"/>
-          <p:cNvSpPr txBox="1"/>
-          <p:nvPr/>
-        </p:nvSpPr>
-        <p:spPr>
-          <a:xfrm>
-            <a:off x="6858000" y="2377440"/>
-            <a:ext cx="4846320" cy="731520"/>
-          </a:xfrm>
-          <a:prstGeom prst="rect">
-            <a:avLst/>
-          </a:prstGeom>
-          <a:noFill/>
-        </p:spPr>
-        <p:txBody>
-          <a:bodyPr wrap="square" lIns="45720" rIns="45720" tIns="18288" bIns="18288">
-            <a:noAutofit/>
-          </a:bodyPr>
-          <a:lstStyle/>
-          <a:p>
-            <a:pPr algn="l"/>
-            <a:r>
-              <a:rPr sz="2200" b="0">
-                <a:solidFill>
-                  <a:srgbClr val="254537"/>
-                </a:solidFill>
-                <a:latin typeface="Microsoft YaHei"/>
-                <a:ea typeface="Microsoft YaHei"/>
-              </a:rPr>
-              <a:t>10月21日，在重庆的世界科技与发展论坛上，科学家发布了十大前瞻技术。</a:t>
-            </a:r>
-          </a:p>
-        </p:txBody>
-      </p:sp>
-      <p:sp>
-        <p:nvSpPr>
-          <p:cNvPr id="10" name="TextBox 9"/>
-          <p:cNvSpPr txBox="1"/>
-          <p:nvPr/>
-        </p:nvSpPr>
-        <p:spPr>
-          <a:xfrm>
-            <a:off x="6858000" y="3200400"/>
-            <a:ext cx="4846320" cy="731520"/>
-          </a:xfrm>
-          <a:prstGeom prst="rect">
-            <a:avLst/>
-          </a:prstGeom>
-          <a:noFill/>
-        </p:spPr>
-        <p:txBody>
-          <a:bodyPr wrap="square" lIns="45720" rIns="45720" tIns="18288" bIns="18288">
-            <a:noAutofit/>
-          </a:bodyPr>
-          <a:lstStyle/>
-          <a:p>
-            <a:pPr algn="l"/>
-            <a:r>
-              <a:rPr sz="2200" b="0">
-                <a:solidFill>
-                  <a:srgbClr val="254537"/>
-                </a:solidFill>
-                <a:latin typeface="Microsoft YaHei"/>
-                <a:ea typeface="Microsoft YaHei"/>
-              </a:rPr>
-              <a:t>这些技术包括会自己做实验的AI、脑机接口、基因编辑等。</a:t>
-            </a:r>
-          </a:p>
-        </p:txBody>
-      </p:sp>
-      <p:sp>
-        <p:nvSpPr>
-          <p:cNvPr id="11" name="Rounded Rectangle 10"/>
+              <a:t>雪豹的大尾巴像围巾</a:t>
+            </a:r>
+          </a:p>
+        </p:txBody>
+      </p:sp>
+      <p:sp>
+        <p:nvSpPr>
+          <p:cNvPr id="9" name="Rounded Rectangle 8"/>
           <p:cNvSpPr/>
           <p:nvPr/>
         </p:nvSpPr>
         <p:spPr>
           <a:xfrm>
-            <a:off x="6858000" y="4206240"/>
-            <a:ext cx="4846320" cy="685800"/>
+            <a:off x="7223760" y="2057400"/>
+            <a:ext cx="2057400" cy="658368"/>
           </a:xfrm>
           <a:prstGeom prst="roundRect">
             <a:avLst/>
           </a:prstGeom>
           <a:solidFill>
-            <a:srgbClr val="FFF6E5"/>
+            <a:srgbClr val="E8F0E5"/>
           </a:solidFill>
           <a:ln>
             <a:noFill/>
@@ -5216,14 +5144,14 @@
       </p:sp>
       <p:sp>
         <p:nvSpPr>
-          <p:cNvPr id="12" name="TextBox 11"/>
+          <p:cNvPr id="10" name="TextBox 9"/>
           <p:cNvSpPr txBox="1"/>
           <p:nvPr/>
         </p:nvSpPr>
         <p:spPr>
           <a:xfrm>
-            <a:off x="6949440" y="4251960"/>
-            <a:ext cx="4663440" cy="594360"/>
+            <a:off x="7315200" y="2157984"/>
+            <a:ext cx="1874519" cy="457200"/>
           </a:xfrm>
           <a:prstGeom prst="rect">
             <a:avLst/>
@@ -5236,30 +5164,214 @@
           </a:bodyPr>
           <a:lstStyle/>
           <a:p>
-            <a:pPr algn="l"/>
-            <a:r>
-              <a:rPr sz="1800" b="1">
+            <a:pPr algn="ctr"/>
+            <a:r>
+              <a:rPr sz="2400" b="1">
+                <a:solidFill>
+                  <a:srgbClr val="254537"/>
+                </a:solidFill>
+                <a:latin typeface="Microsoft YaHei"/>
+                <a:ea typeface="Microsoft YaHei"/>
+              </a:rPr>
+              <a:t>住在高山</a:t>
+            </a:r>
+          </a:p>
+        </p:txBody>
+      </p:sp>
+      <p:sp>
+        <p:nvSpPr>
+          <p:cNvPr id="11" name="Rounded Rectangle 10"/>
+          <p:cNvSpPr/>
+          <p:nvPr/>
+        </p:nvSpPr>
+        <p:spPr>
+          <a:xfrm>
+            <a:off x="9509760" y="2057400"/>
+            <a:ext cx="2194560" cy="658368"/>
+          </a:xfrm>
+          <a:prstGeom prst="roundRect">
+            <a:avLst/>
+          </a:prstGeom>
+          <a:solidFill>
+            <a:srgbClr val="E8F0E5"/>
+          </a:solidFill>
+          <a:ln>
+            <a:noFill/>
+          </a:ln>
+          <a:effectLst/>
+        </p:spPr>
+        <p:style>
+          <a:lnRef idx="1">
+            <a:schemeClr val="accent1"/>
+          </a:lnRef>
+          <a:fillRef idx="3">
+            <a:schemeClr val="accent1"/>
+          </a:fillRef>
+          <a:effectRef idx="2">
+            <a:schemeClr val="accent1"/>
+          </a:effectRef>
+          <a:fontRef idx="minor">
+            <a:schemeClr val="lt1"/>
+          </a:fontRef>
+        </p:style>
+        <p:txBody>
+          <a:bodyPr rtlCol="0" anchor="ctr"/>
+          <a:lstStyle/>
+          <a:p>
+            <a:pPr algn="ctr"/>
+          </a:p>
+        </p:txBody>
+      </p:sp>
+      <p:sp>
+        <p:nvSpPr>
+          <p:cNvPr id="12" name="TextBox 11"/>
+          <p:cNvSpPr txBox="1"/>
+          <p:nvPr/>
+        </p:nvSpPr>
+        <p:spPr>
+          <a:xfrm>
+            <a:off x="9601200" y="2157984"/>
+            <a:ext cx="2011680" cy="457200"/>
+          </a:xfrm>
+          <a:prstGeom prst="rect">
+            <a:avLst/>
+          </a:prstGeom>
+          <a:noFill/>
+        </p:spPr>
+        <p:txBody>
+          <a:bodyPr wrap="square" lIns="45720" rIns="45720" tIns="18288" bIns="18288">
+            <a:noAutofit/>
+          </a:bodyPr>
+          <a:lstStyle/>
+          <a:p>
+            <a:pPr algn="ctr"/>
+            <a:r>
+              <a:rPr sz="2400" b="1">
+                <a:solidFill>
+                  <a:srgbClr val="254537"/>
+                </a:solidFill>
+                <a:latin typeface="Microsoft YaHei"/>
+                <a:ea typeface="Microsoft YaHei"/>
+              </a:rPr>
+              <a:t>厚毛不怕冷</a:t>
+            </a:r>
+          </a:p>
+        </p:txBody>
+      </p:sp>
+      <p:sp>
+        <p:nvSpPr>
+          <p:cNvPr id="13" name="Rounded Rectangle 12"/>
+          <p:cNvSpPr/>
+          <p:nvPr/>
+        </p:nvSpPr>
+        <p:spPr>
+          <a:xfrm>
+            <a:off x="7223760" y="2971800"/>
+            <a:ext cx="4480560" cy="749808"/>
+          </a:xfrm>
+          <a:prstGeom prst="roundRect">
+            <a:avLst/>
+          </a:prstGeom>
+          <a:solidFill>
+            <a:srgbClr val="FFF6E5"/>
+          </a:solidFill>
+          <a:ln>
+            <a:noFill/>
+          </a:ln>
+          <a:effectLst/>
+        </p:spPr>
+        <p:style>
+          <a:lnRef idx="1">
+            <a:schemeClr val="accent1"/>
+          </a:lnRef>
+          <a:fillRef idx="3">
+            <a:schemeClr val="accent1"/>
+          </a:fillRef>
+          <a:effectRef idx="2">
+            <a:schemeClr val="accent1"/>
+          </a:effectRef>
+          <a:fontRef idx="minor">
+            <a:schemeClr val="lt1"/>
+          </a:fontRef>
+        </p:style>
+        <p:txBody>
+          <a:bodyPr rtlCol="0" anchor="ctr"/>
+          <a:lstStyle/>
+          <a:p>
+            <a:pPr algn="ctr"/>
+          </a:p>
+        </p:txBody>
+      </p:sp>
+      <p:sp>
+        <p:nvSpPr>
+          <p:cNvPr id="14" name="TextBox 13"/>
+          <p:cNvSpPr txBox="1"/>
+          <p:nvPr/>
+        </p:nvSpPr>
+        <p:spPr>
+          <a:xfrm>
+            <a:off x="7360920" y="3090672"/>
+            <a:ext cx="4206240" cy="502920"/>
+          </a:xfrm>
+          <a:prstGeom prst="rect">
+            <a:avLst/>
+          </a:prstGeom>
+          <a:noFill/>
+        </p:spPr>
+        <p:txBody>
+          <a:bodyPr wrap="square" lIns="45720" rIns="45720" tIns="18288" bIns="18288">
+            <a:noAutofit/>
+          </a:bodyPr>
+          <a:lstStyle/>
+          <a:p>
+            <a:pPr algn="ctr"/>
+            <a:r>
+              <a:rPr sz="2200" b="1">
                 <a:solidFill>
                   <a:srgbClr val="BC4F32"/>
                 </a:solidFill>
                 <a:latin typeface="Microsoft YaHei"/>
                 <a:ea typeface="Microsoft YaHei"/>
               </a:rPr>
-              <a:t>这些新技术可能会改变我们的生活，让未来更美好。</a:t>
-            </a:r>
-          </a:p>
-        </p:txBody>
-      </p:sp>
-      <p:sp>
-        <p:nvSpPr>
-          <p:cNvPr id="13" name="TextBox 12"/>
+              <a:t>大尾巴：走路稳，还能保暖</a:t>
+            </a:r>
+          </a:p>
+        </p:txBody>
+      </p:sp>
+      <p:pic>
+        <p:nvPicPr>
+          <p:cNvPr id="15" name="Picture 14" descr="snow-leopard.gif"/>
+          <p:cNvPicPr>
+            <a:picLocks noChangeAspect="1"/>
+          </p:cNvPicPr>
+          <p:nvPr/>
+        </p:nvPicPr>
+        <p:blipFill>
+          <a:blip r:embed="rId3"/>
+          <a:stretch>
+            <a:fillRect/>
+          </a:stretch>
+        </p:blipFill>
+        <p:spPr>
+          <a:xfrm>
+            <a:off x="7635240" y="4069080"/>
+            <a:ext cx="3657600" cy="1432560"/>
+          </a:xfrm>
+          <a:prstGeom prst="rect">
+            <a:avLst/>
+          </a:prstGeom>
+        </p:spPr>
+      </p:pic>
+      <p:sp>
+        <p:nvSpPr>
+          <p:cNvPr id="16" name="TextBox 15"/>
           <p:cNvSpPr txBox="1"/>
           <p:nvPr/>
         </p:nvSpPr>
         <p:spPr>
           <a:xfrm>
-            <a:off x="548640" y="6400800"/>
-            <a:ext cx="5486400" cy="320040"/>
+            <a:off x="7635240" y="5577840"/>
+            <a:ext cx="3657600" cy="320040"/>
           </a:xfrm>
           <a:prstGeom prst="rect">
             <a:avLst/>
@@ -5272,30 +5384,66 @@
           </a:bodyPr>
           <a:lstStyle/>
           <a:p>
-            <a:pPr algn="l"/>
-            <a:r>
-              <a:rPr sz="1000" b="0">
+            <a:pPr algn="ctr"/>
+            <a:r>
+              <a:rPr sz="1300" b="0">
                 <a:solidFill>
                   <a:srgbClr val="52665B"/>
                 </a:solidFill>
                 <a:latin typeface="Microsoft YaHei"/>
                 <a:ea typeface="Microsoft YaHei"/>
               </a:rPr>
-              <a:t>小小新闻播报 · 2026年10月27日 星期二</a:t>
-            </a:r>
-          </a:p>
-        </p:txBody>
-      </p:sp>
-      <p:sp>
-        <p:nvSpPr>
-          <p:cNvPr id="14" name="TextBox 13"/>
+              <a:t>放映时，小雪豹会走起来</a:t>
+            </a:r>
+          </a:p>
+        </p:txBody>
+      </p:sp>
+      <p:sp>
+        <p:nvSpPr>
+          <p:cNvPr id="17" name="TextBox 16"/>
           <p:cNvSpPr txBox="1"/>
           <p:nvPr/>
         </p:nvSpPr>
         <p:spPr>
           <a:xfrm>
-            <a:off x="6858000" y="6400800"/>
-            <a:ext cx="4846320" cy="320040"/>
+            <a:off x="548640" y="6400800"/>
+            <a:ext cx="5852160" cy="274320"/>
+          </a:xfrm>
+          <a:prstGeom prst="rect">
+            <a:avLst/>
+          </a:prstGeom>
+          <a:noFill/>
+        </p:spPr>
+        <p:txBody>
+          <a:bodyPr wrap="square" lIns="45720" rIns="45720" tIns="18288" bIns="18288">
+            <a:noAutofit/>
+          </a:bodyPr>
+          <a:lstStyle/>
+          <a:p>
+            <a:pPr algn="l"/>
+            <a:r>
+              <a:rPr sz="900" b="0">
+                <a:solidFill>
+                  <a:srgbClr val="52665B"/>
+                </a:solidFill>
+                <a:latin typeface="Microsoft YaHei"/>
+                <a:ea typeface="Microsoft YaHei"/>
+              </a:rPr>
+              <a:t>新华社 / 国家林业和草原局 · 2026-10-23</a:t>
+            </a:r>
+          </a:p>
+        </p:txBody>
+      </p:sp>
+      <p:sp>
+        <p:nvSpPr>
+          <p:cNvPr id="18" name="TextBox 17"/>
+          <p:cNvSpPr txBox="1"/>
+          <p:nvPr/>
+        </p:nvSpPr>
+        <p:spPr>
+          <a:xfrm>
+            <a:off x="8961120" y="6400800"/>
+            <a:ext cx="2743200" cy="274320"/>
           </a:xfrm>
           <a:prstGeom prst="rect">
             <a:avLst/>
@@ -5338,152 +5486,12 @@
                   <p:par>
                     <p:cT id="3" fill="hold">
                       <p:stCondLst>
-                        <p:cond delay="0"/>
+                        <p:cond delay="200"/>
                       </p:stCondLst>
                       <p:childTnLst>
                         <p:set>
                           <p:cBhvr>
                             <p:cT id="4" dur="1" fill="hold">
-                              <p:stCondLst>
-                                <p:cond delay="0"/>
-                              </p:stCondLst>
-                            </p:cT>
-                            <p:tgtEl>
-                              <p:spTgt spid="2"/>
-                            </p:tgtEl>
-                            <p:attrNameLst>
-                              <p:attrName>style.visibility</p:attrName>
-                            </p:attrNameLst>
-                          </p:cBhvr>
-                          <p:to>
-                            <p:strVal val="visible"/>
-                          </p:to>
-                        </p:set>
-                        <p:animEffect transition="in" filter="fade">
-                          <p:cBhvr>
-                            <p:cT id="5" dur="300"/>
-                            <p:tgtEl>
-                              <p:spTgt spid="2"/>
-                            </p:tgtEl>
-                          </p:cBhvr>
-                        </p:animEffect>
-                      </p:childTnLst>
-                    </p:cT>
-                  </p:par>
-                  <p:par>
-                    <p:cT id="4" fill="hold">
-                      <p:stCondLst>
-                        <p:cond delay="200"/>
-                      </p:stCondLst>
-                      <p:childTnLst>
-                        <p:set>
-                          <p:cBhvr>
-                            <p:cT id="5" dur="1" fill="hold">
-                              <p:stCondLst>
-                                <p:cond delay="0"/>
-                              </p:stCondLst>
-                            </p:cT>
-                            <p:tgtEl>
-                              <p:spTgt spid="3"/>
-                            </p:tgtEl>
-                            <p:attrNameLst>
-                              <p:attrName>style.visibility</p:attrName>
-                            </p:attrNameLst>
-                          </p:cBhvr>
-                          <p:to>
-                            <p:strVal val="visible"/>
-                          </p:to>
-                        </p:set>
-                        <p:animEffect transition="in" filter="fade">
-                          <p:cBhvr>
-                            <p:cT id="6" dur="400"/>
-                            <p:tgtEl>
-                              <p:spTgt spid="3"/>
-                            </p:tgtEl>
-                          </p:cBhvr>
-                        </p:animEffect>
-                      </p:childTnLst>
-                    </p:cT>
-                  </p:par>
-                  <p:par>
-                    <p:cT id="5" fill="hold">
-                      <p:stCondLst>
-                        <p:cond delay="300"/>
-                      </p:stCondLst>
-                      <p:childTnLst>
-                        <p:set>
-                          <p:cBhvr>
-                            <p:cT id="6" dur="1" fill="hold">
-                              <p:stCondLst>
-                                <p:cond delay="0"/>
-                              </p:stCondLst>
-                            </p:cT>
-                            <p:tgtEl>
-                              <p:spTgt spid="5"/>
-                            </p:tgtEl>
-                            <p:attrNameLst>
-                              <p:attrName>style.visibility</p:attrName>
-                            </p:attrNameLst>
-                          </p:cBhvr>
-                          <p:to>
-                            <p:strVal val="visible"/>
-                          </p:to>
-                        </p:set>
-                        <p:animEffect transition="in" filter="fade">
-                          <p:cBhvr>
-                            <p:cT id="7" dur="400"/>
-                            <p:tgtEl>
-                              <p:spTgt spid="5"/>
-                            </p:tgtEl>
-                          </p:cBhvr>
-                        </p:animEffect>
-                      </p:childTnLst>
-                    </p:cT>
-                  </p:par>
-                  <p:par>
-                    <p:cT id="6" fill="hold">
-                      <p:stCondLst>
-                        <p:cond delay="400"/>
-                      </p:stCondLst>
-                      <p:childTnLst>
-                        <p:set>
-                          <p:cBhvr>
-                            <p:cT id="7" dur="1" fill="hold">
-                              <p:stCondLst>
-                                <p:cond delay="0"/>
-                              </p:stCondLst>
-                            </p:cT>
-                            <p:tgtEl>
-                              <p:spTgt spid="6"/>
-                            </p:tgtEl>
-                            <p:attrNameLst>
-                              <p:attrName>style.visibility</p:attrName>
-                            </p:attrNameLst>
-                          </p:cBhvr>
-                          <p:to>
-                            <p:strVal val="visible"/>
-                          </p:to>
-                        </p:set>
-                        <p:animEffect transition="in" filter="fade">
-                          <p:cBhvr>
-                            <p:cT id="8" dur="500"/>
-                            <p:tgtEl>
-                              <p:spTgt spid="6"/>
-                            </p:tgtEl>
-                          </p:cBhvr>
-                        </p:animEffect>
-                      </p:childTnLst>
-                    </p:cT>
-                  </p:par>
-                  <p:par>
-                    <p:cT id="7" fill="hold">
-                      <p:stCondLst>
-                        <p:cond delay="600"/>
-                      </p:stCondLst>
-                      <p:childTnLst>
-                        <p:set>
-                          <p:cBhvr>
-                            <p:cT id="8" dur="1" fill="hold">
                               <p:stCondLst>
                                 <p:cond delay="0"/>
                               </p:stCondLst>
@@ -5501,7 +5509,7 @@
                         </p:set>
                         <p:animEffect transition="in" filter="fade">
                           <p:cBhvr>
-                            <p:cT id="9" dur="500"/>
+                            <p:cT id="5" dur="450"/>
                             <p:tgtEl>
                               <p:spTgt spid="8"/>
                             </p:tgtEl>
@@ -5511,14 +5519,14 @@
                     </p:cT>
                   </p:par>
                   <p:par>
-                    <p:cT id="8" fill="hold">
+                    <p:cT id="4" fill="hold">
                       <p:stCondLst>
-                        <p:cond delay="800"/>
+                        <p:cond delay="450"/>
                       </p:stCondLst>
                       <p:childTnLst>
                         <p:set>
                           <p:cBhvr>
-                            <p:cT id="9" dur="1" fill="hold">
+                            <p:cT id="5" dur="1" fill="hold">
                               <p:stCondLst>
                                 <p:cond delay="0"/>
                               </p:stCondLst>
@@ -5536,7 +5544,7 @@
                         </p:set>
                         <p:animEffect transition="in" filter="fade">
                           <p:cBhvr>
-                            <p:cT id="10" dur="500"/>
+                            <p:cT id="6" dur="400"/>
                             <p:tgtEl>
                               <p:spTgt spid="9"/>
                             </p:tgtEl>
@@ -5546,49 +5554,14 @@
                     </p:cT>
                   </p:par>
                   <p:par>
-                    <p:cT id="9" fill="hold">
+                    <p:cT id="5" fill="hold">
                       <p:stCondLst>
-                        <p:cond delay="1000"/>
+                        <p:cond delay="650"/>
                       </p:stCondLst>
                       <p:childTnLst>
                         <p:set>
                           <p:cBhvr>
-                            <p:cT id="10" dur="1" fill="hold">
-                              <p:stCondLst>
-                                <p:cond delay="0"/>
-                              </p:stCondLst>
-                            </p:cT>
-                            <p:tgtEl>
-                              <p:spTgt spid="10"/>
-                            </p:tgtEl>
-                            <p:attrNameLst>
-                              <p:attrName>style.visibility</p:attrName>
-                            </p:attrNameLst>
-                          </p:cBhvr>
-                          <p:to>
-                            <p:strVal val="visible"/>
-                          </p:to>
-                        </p:set>
-                        <p:animEffect transition="in" filter="fade">
-                          <p:cBhvr>
-                            <p:cT id="11" dur="500"/>
-                            <p:tgtEl>
-                              <p:spTgt spid="10"/>
-                            </p:tgtEl>
-                          </p:cBhvr>
-                        </p:animEffect>
-                      </p:childTnLst>
-                    </p:cT>
-                  </p:par>
-                  <p:par>
-                    <p:cT id="10" fill="hold">
-                      <p:stCondLst>
-                        <p:cond delay="1200"/>
-                      </p:stCondLst>
-                      <p:childTnLst>
-                        <p:set>
-                          <p:cBhvr>
-                            <p:cT id="11" dur="1" fill="hold">
+                            <p:cT id="6" dur="1" fill="hold">
                               <p:stCondLst>
                                 <p:cond delay="0"/>
                               </p:stCondLst>
@@ -5606,7 +5579,7 @@
                         </p:set>
                         <p:animEffect transition="in" filter="fade">
                           <p:cBhvr>
-                            <p:cT id="12" dur="500"/>
+                            <p:cT id="7" dur="400"/>
                             <p:tgtEl>
                               <p:spTgt spid="11"/>
                             </p:tgtEl>
@@ -5616,14 +5589,14 @@
                     </p:cT>
                   </p:par>
                   <p:par>
-                    <p:cT id="11" fill="hold">
+                    <p:cT id="6" fill="hold">
                       <p:stCondLst>
-                        <p:cond delay="1400"/>
+                        <p:cond delay="850"/>
                       </p:stCondLst>
                       <p:childTnLst>
                         <p:set>
                           <p:cBhvr>
-                            <p:cT id="12" dur="1" fill="hold">
+                            <p:cT id="7" dur="1" fill="hold">
                               <p:stCondLst>
                                 <p:cond delay="0"/>
                               </p:stCondLst>
@@ -5641,44 +5614,9 @@
                         </p:set>
                         <p:animEffect transition="in" filter="fade">
                           <p:cBhvr>
-                            <p:cT id="13" dur="400"/>
+                            <p:cT id="8" dur="450"/>
                             <p:tgtEl>
                               <p:spTgt spid="13"/>
-                            </p:tgtEl>
-                          </p:cBhvr>
-                        </p:animEffect>
-                      </p:childTnLst>
-                    </p:cT>
-                  </p:par>
-                  <p:par>
-                    <p:cT id="12" fill="hold">
-                      <p:stCondLst>
-                        <p:cond delay="1400"/>
-                      </p:stCondLst>
-                      <p:childTnLst>
-                        <p:set>
-                          <p:cBhvr>
-                            <p:cT id="13" dur="1" fill="hold">
-                              <p:stCondLst>
-                                <p:cond delay="0"/>
-                              </p:stCondLst>
-                            </p:cT>
-                            <p:tgtEl>
-                              <p:spTgt spid="14"/>
-                            </p:tgtEl>
-                            <p:attrNameLst>
-                              <p:attrName>style.visibility</p:attrName>
-                            </p:attrNameLst>
-                          </p:cBhvr>
-                          <p:to>
-                            <p:strVal val="visible"/>
-                          </p:to>
-                        </p:set>
-                        <p:animEffect transition="in" filter="fade">
-                          <p:cBhvr>
-                            <p:cT id="14" dur="400"/>
-                            <p:tgtEl>
-                              <p:spTgt spid="14"/>
                             </p:tgtEl>
                           </p:cBhvr>
                         </p:animEffect>

</xml_diff>

<commit_message>
Simplify the snow leopard introduction for young children
Use shorter, familiar wording across the webpage, presenter script, and animated PPT slide.
</commit_message>
<xml_diff>
--- a/daily-news/2026-10-27/今日新闻-2026-10-27.pptx
+++ b/daily-news/2026-10-27/今日新闻-2026-10-27.pptx
@@ -5173,7 +5173,7 @@
                 <a:latin typeface="Microsoft YaHei"/>
                 <a:ea typeface="Microsoft YaHei"/>
               </a:rPr>
-              <a:t>住在高山</a:t>
+              <a:t>住在高山上</a:t>
             </a:r>
           </a:p>
         </p:txBody>
@@ -5253,7 +5253,7 @@
                 <a:latin typeface="Microsoft YaHei"/>
                 <a:ea typeface="Microsoft YaHei"/>
               </a:rPr>
-              <a:t>厚毛不怕冷</a:t>
+              <a:t>厚厚的皮毛</a:t>
             </a:r>
           </a:p>
         </p:txBody>
@@ -5333,7 +5333,7 @@
                 <a:latin typeface="Microsoft YaHei"/>
                 <a:ea typeface="Microsoft YaHei"/>
               </a:rPr>
-              <a:t>大尾巴：走路稳，还能保暖</a:t>
+              <a:t>大大的尾巴：走路稳，还能保暖</a:t>
             </a:r>
           </a:p>
         </p:txBody>

</xml_diff>

<commit_message>
Restore the full snow leopard copy in the PPT
Match the third slide to the webpage text while retaining the large photo and animated snow leopard.
</commit_message>
<xml_diff>
--- a/daily-news/2026-10-27/今日新闻-2026-10-27.pptx
+++ b/daily-news/2026-10-27/今日新闻-2026-10-27.pptx
@@ -5106,8 +5106,8 @@
         </p:nvSpPr>
         <p:spPr>
           <a:xfrm>
-            <a:off x="7223760" y="2057400"/>
-            <a:ext cx="2057400" cy="658368"/>
+            <a:off x="7223760" y="1965960"/>
+            <a:ext cx="4480560" cy="658368"/>
           </a:xfrm>
           <a:prstGeom prst="roundRect">
             <a:avLst/>
@@ -5150,8 +5150,8 @@
         </p:nvSpPr>
         <p:spPr>
           <a:xfrm>
-            <a:off x="7315200" y="2157984"/>
-            <a:ext cx="1874519" cy="457200"/>
+            <a:off x="7406640" y="2075688"/>
+            <a:ext cx="4114800" cy="438912"/>
           </a:xfrm>
           <a:prstGeom prst="rect">
             <a:avLst/>
@@ -5164,7 +5164,7 @@
           </a:bodyPr>
           <a:lstStyle/>
           <a:p>
-            <a:pPr algn="ctr"/>
+            <a:pPr algn="l"/>
             <a:r>
               <a:rPr sz="2400" b="1">
                 <a:solidFill>
@@ -5173,7 +5173,7 @@
                 <a:latin typeface="Microsoft YaHei"/>
                 <a:ea typeface="Microsoft YaHei"/>
               </a:rPr>
-              <a:t>住在高山上</a:t>
+              <a:t>雪豹住在高山上。</a:t>
             </a:r>
           </a:p>
         </p:txBody>
@@ -5186,14 +5186,14 @@
         </p:nvSpPr>
         <p:spPr>
           <a:xfrm>
-            <a:off x="9509760" y="2057400"/>
-            <a:ext cx="2194560" cy="658368"/>
+            <a:off x="7223760" y="2788920"/>
+            <a:ext cx="4480560" cy="1261872"/>
           </a:xfrm>
           <a:prstGeom prst="roundRect">
             <a:avLst/>
           </a:prstGeom>
           <a:solidFill>
-            <a:srgbClr val="E8F0E5"/>
+            <a:srgbClr val="FFFFFF"/>
           </a:solidFill>
           <a:ln>
             <a:noFill/>
@@ -5230,8 +5230,8 @@
         </p:nvSpPr>
         <p:spPr>
           <a:xfrm>
-            <a:off x="9601200" y="2157984"/>
-            <a:ext cx="2011680" cy="457200"/>
+            <a:off x="7424927" y="2926080"/>
+            <a:ext cx="4069080" cy="987552"/>
           </a:xfrm>
           <a:prstGeom prst="rect">
             <a:avLst/>
@@ -5244,16 +5244,16 @@
           </a:bodyPr>
           <a:lstStyle/>
           <a:p>
-            <a:pPr algn="ctr"/>
-            <a:r>
-              <a:rPr sz="2400" b="1">
+            <a:pPr algn="l"/>
+            <a:r>
+              <a:rPr sz="2000" b="0">
                 <a:solidFill>
                   <a:srgbClr val="254537"/>
                 </a:solidFill>
                 <a:latin typeface="Microsoft YaHei"/>
                 <a:ea typeface="Microsoft YaHei"/>
               </a:rPr>
-              <a:t>厚厚的皮毛</a:t>
+              <a:t>它有厚厚的皮毛和大大的尾巴，走起路来很稳，而且还能保暖。</a:t>
             </a:r>
           </a:p>
         </p:txBody>
@@ -5266,8 +5266,8 @@
         </p:nvSpPr>
         <p:spPr>
           <a:xfrm>
-            <a:off x="7223760" y="2971800"/>
-            <a:ext cx="4480560" cy="749808"/>
+            <a:off x="7223760" y="4224528"/>
+            <a:ext cx="4480560" cy="676656"/>
           </a:xfrm>
           <a:prstGeom prst="roundRect">
             <a:avLst/>
@@ -5310,8 +5310,8 @@
         </p:nvSpPr>
         <p:spPr>
           <a:xfrm>
-            <a:off x="7360920" y="3090672"/>
-            <a:ext cx="4206240" cy="502920"/>
+            <a:off x="7360920" y="4334256"/>
+            <a:ext cx="4206240" cy="438912"/>
           </a:xfrm>
           <a:prstGeom prst="rect">
             <a:avLst/>
@@ -5326,14 +5326,14 @@
           <a:p>
             <a:pPr algn="ctr"/>
             <a:r>
-              <a:rPr sz="2200" b="1">
+              <a:rPr sz="1800" b="1">
                 <a:solidFill>
                   <a:srgbClr val="BC4F32"/>
                 </a:solidFill>
                 <a:latin typeface="Microsoft YaHei"/>
                 <a:ea typeface="Microsoft YaHei"/>
               </a:rPr>
-              <a:t>大大的尾巴：走路稳，还能保暖</a:t>
+              <a:t>想一想：雪豹的大尾巴还像什么？</a:t>
             </a:r>
           </a:p>
         </p:txBody>
@@ -5354,8 +5354,8 @@
         </p:blipFill>
         <p:spPr>
           <a:xfrm>
-            <a:off x="7635240" y="4069080"/>
-            <a:ext cx="3657600" cy="1432560"/>
+            <a:off x="8092440" y="5074920"/>
+            <a:ext cx="2743200" cy="1074420"/>
           </a:xfrm>
           <a:prstGeom prst="rect">
             <a:avLst/>
@@ -5370,8 +5370,8 @@
         </p:nvSpPr>
         <p:spPr>
           <a:xfrm>
-            <a:off x="7635240" y="5577840"/>
-            <a:ext cx="3657600" cy="320040"/>
+            <a:off x="7635240" y="6144768"/>
+            <a:ext cx="3657600" cy="228600"/>
           </a:xfrm>
           <a:prstGeom prst="rect">
             <a:avLst/>
@@ -5386,7 +5386,7 @@
           <a:p>
             <a:pPr algn="ctr"/>
             <a:r>
-              <a:rPr sz="1300" b="0">
+              <a:rPr sz="1100" b="0">
                 <a:solidFill>
                   <a:srgbClr val="52665B"/>
                 </a:solidFill>

</xml_diff>